<commit_message>
Desktop terminal: open with the 'ethical vibe coding = oxymoron?' thesis (brain-off vs brain-on); name Remy Stewart as the Wed Figma guest in the deck
Co-Authored-By: Claude Fable 5 <noreply@anthropic.com>
</commit_message>
<xml_diff>
--- a/slides/Week3-Wed-Working-Day.pptx
+++ b/slides/Week3-Wed-Working-Day.pptx
@@ -3900,7 +3900,7 @@
                 </a:solidFill>
                 <a:latin typeface="Arial"/>
               </a:rPr>
-              <a:t>Guest lecture today: Figma. Bring your questions about design + prototyping.</a:t>
+              <a:t>Guest lecture today: Remy Stewart (Figma). Bring your questions about design + prototyping.</a:t>
             </a:r>
           </a:p>
         </p:txBody>
@@ -4167,7 +4167,7 @@
                 </a:solidFill>
                 <a:latin typeface="Arial"/>
               </a:rPr>
-              <a:t>Open with the Figma guest talk, then find the real need.</a:t>
+              <a:t>Open with Remy Stewart's Figma guest talk, then find the real need.</a:t>
             </a:r>
           </a:p>
         </p:txBody>

</xml_diff>

<commit_message>
Wed Planning deck: values-conscientious planning cluster — personas as empathy (not stereotype), get close to the real person (co-design), AI persona vs. real human ('theater or insight?'), and keep the value in the foreground of persona + storyboard
Co-Authored-By: Claude Fable 5 <noreply@anthropic.com>
</commit_message>
<xml_diff>
--- a/slides/Week3-Wed-Working-Day.pptx
+++ b/slides/Week3-Wed-Working-Day.pptx
@@ -15,6 +15,11 @@
     <p:sldId id="263" r:id="rId15"/>
     <p:sldId id="264" r:id="rId16"/>
     <p:sldId id="265" r:id="rId17"/>
+    <p:sldId id="266" r:id="rId18"/>
+    <p:sldId id="267" r:id="rId19"/>
+    <p:sldId id="268" r:id="rId20"/>
+    <p:sldId id="269" r:id="rId21"/>
+    <p:sldId id="270" r:id="rId22"/>
   </p:sldIdLst>
   <p:sldSz cx="12191695" cy="6858000" type="screen4x3"/>
   <p:notesSz cx="6858000" cy="9144000"/>
@@ -467,6 +472,76 @@
 </file>
 
 <file path=ppt/notesSlides/notesSlide1.xml><?xml version="1.0" encoding="utf-8"?>
+<p:notes xmlns:a="http://schemas.openxmlformats.org/drawingml/2006/main" xmlns:p="http://schemas.openxmlformats.org/presentationml/2006/main" xmlns:r="http://schemas.openxmlformats.org/officeDocument/2006/relationships">
+  <p:cSld>
+    <p:spTree>
+      <p:nvGrpSpPr>
+        <p:cNvPr id="1" name=""/>
+        <p:cNvGrpSpPr/>
+        <p:nvPr/>
+      </p:nvGrpSpPr>
+      <p:grpSpPr>
+        <a:xfrm>
+          <a:off x="0" y="0"/>
+          <a:ext cx="0" cy="0"/>
+          <a:chOff x="0" y="0"/>
+          <a:chExt cx="0" cy="0"/>
+        </a:xfrm>
+      </p:grpSpPr>
+      <p:sp>
+        <p:nvSpPr>
+          <p:cNvPr id="2" name="Slide Image Placeholder 1"/>
+          <p:cNvSpPr>
+            <a:spLocks noGrp="1"/>
+          </p:cNvSpPr>
+          <p:nvPr>
+            <p:ph type="sldImg" idx="2"/>
+          </p:nvPr>
+        </p:nvSpPr>
+        <p:spPr/>
+      </p:sp>
+      <p:sp>
+        <p:nvSpPr>
+          <p:cNvPr id="3" name="Notes Placeholder 2"/>
+          <p:cNvSpPr>
+            <a:spLocks noGrp="1"/>
+          </p:cNvSpPr>
+          <p:nvPr>
+            <p:ph type="body" idx="3" sz="quarter"/>
+          </p:nvPr>
+        </p:nvSpPr>
+        <p:spPr/>
+        <p:txBody>
+          <a:bodyPr/>
+          <a:lstStyle/>
+          <a:p>
+            <a:r>
+              <a:t>AI personas are fast + frictionless but can launder assumptions back as 'data'. Comparing to a real human is the check.</a:t>
+            </a:r>
+          </a:p>
+        </p:txBody>
+      </p:sp>
+      <p:sp>
+        <p:nvSpPr>
+          <p:cNvPr id="4" name="Slide Number Placeholder 3"/>
+          <p:cNvSpPr>
+            <a:spLocks noGrp="1"/>
+          </p:cNvSpPr>
+          <p:nvPr>
+            <p:ph type="sldNum" idx="5" sz="quarter"/>
+          </p:nvPr>
+        </p:nvSpPr>
+        <p:spPr/>
+      </p:sp>
+    </p:spTree>
+  </p:cSld>
+  <p:clrMapOvr>
+    <a:masterClrMapping/>
+  </p:clrMapOvr>
+</p:notes>
+</file>
+
+<file path=ppt/notesSlides/notesSlide2.xml><?xml version="1.0" encoding="utf-8"?>
 <p:notes xmlns:a="http://schemas.openxmlformats.org/drawingml/2006/main" xmlns:p="http://schemas.openxmlformats.org/presentationml/2006/main" xmlns:r="http://schemas.openxmlformats.org/officeDocument/2006/relationships">
   <p:cSld>
     <p:spTree>
@@ -3746,6 +3821,1641 @@
                 </a:solidFill>
                 <a:latin typeface="Courier New"/>
               </a:rPr>
+              <a:t>OPERATIONALIZE - THE VALUE TREE</a:t>
+            </a:r>
+          </a:p>
+        </p:txBody>
+      </p:sp>
+      <p:sp>
+        <p:nvSpPr>
+          <p:cNvPr id="3" name="Rectangle 2"/>
+          <p:cNvSpPr/>
+          <p:nvPr/>
+        </p:nvSpPr>
+        <p:spPr>
+          <a:xfrm>
+            <a:off x="640080" y="932688"/>
+            <a:ext cx="822960" cy="73152"/>
+          </a:xfrm>
+          <a:prstGeom prst="rect">
+            <a:avLst/>
+          </a:prstGeom>
+          <a:solidFill>
+            <a:srgbClr val="00FF41"/>
+          </a:solidFill>
+          <a:ln>
+            <a:noFill/>
+          </a:ln>
+          <a:effectLst/>
+        </p:spPr>
+        <p:style>
+          <a:lnRef idx="1">
+            <a:schemeClr val="accent1"/>
+          </a:lnRef>
+          <a:fillRef idx="3">
+            <a:schemeClr val="accent1"/>
+          </a:fillRef>
+          <a:effectRef idx="2">
+            <a:schemeClr val="accent1"/>
+          </a:effectRef>
+          <a:fontRef idx="minor">
+            <a:schemeClr val="lt1"/>
+          </a:fontRef>
+        </p:style>
+        <p:txBody>
+          <a:bodyPr rtlCol="0" anchor="ctr"/>
+          <a:lstStyle/>
+          <a:p>
+            <a:pPr algn="ctr"/>
+          </a:p>
+        </p:txBody>
+      </p:sp>
+      <p:sp>
+        <p:nvSpPr>
+          <p:cNvPr id="4" name="TextBox 3"/>
+          <p:cNvSpPr txBox="1"/>
+          <p:nvPr/>
+        </p:nvSpPr>
+        <p:spPr>
+          <a:xfrm>
+            <a:off x="640080" y="1188720"/>
+            <a:ext cx="10972800" cy="1097280"/>
+          </a:xfrm>
+          <a:prstGeom prst="rect">
+            <a:avLst/>
+          </a:prstGeom>
+          <a:noFill/>
+        </p:spPr>
+        <p:txBody>
+          <a:bodyPr wrap="square" anchor="t">
+            <a:spAutoFit/>
+          </a:bodyPr>
+          <a:lstStyle/>
+          <a:p>
+            <a:pPr algn="l">
+              <a:lnSpc>
+                <a:spcPct val="100000"/>
+              </a:lnSpc>
+            </a:pPr>
+            <a:r>
+              <a:rPr sz="3400" b="1">
+                <a:solidFill>
+                  <a:srgbClr val="F5F7FA"/>
+                </a:solidFill>
+                <a:latin typeface="Arial"/>
+              </a:rPr>
+              <a:t>From value down to the prompts you'll build</a:t>
+            </a:r>
+          </a:p>
+        </p:txBody>
+      </p:sp>
+      <p:sp>
+        <p:nvSpPr>
+          <p:cNvPr id="5" name="TextBox 4"/>
+          <p:cNvSpPr txBox="1"/>
+          <p:nvPr/>
+        </p:nvSpPr>
+        <p:spPr>
+          <a:xfrm>
+            <a:off x="658368" y="2286000"/>
+            <a:ext cx="10881360" cy="3657600"/>
+          </a:xfrm>
+          <a:prstGeom prst="rect">
+            <a:avLst/>
+          </a:prstGeom>
+          <a:noFill/>
+        </p:spPr>
+        <p:txBody>
+          <a:bodyPr wrap="square" anchor="t">
+            <a:spAutoFit/>
+          </a:bodyPr>
+          <a:lstStyle/>
+          <a:p>
+            <a:pPr algn="l">
+              <a:lnSpc>
+                <a:spcPct val="112000"/>
+              </a:lnSpc>
+            </a:pPr>
+            <a:r>
+              <a:rPr sz="2000" b="0">
+                <a:solidFill>
+                  <a:srgbClr val="F5F7FA"/>
+                </a:solidFill>
+                <a:latin typeface="Arial"/>
+              </a:rPr>
+              <a:t>Break your value down until it becomes something you can actually build:</a:t>
+            </a:r>
+          </a:p>
+          <a:p>
+            <a:pPr algn="l">
+              <a:lnSpc>
+                <a:spcPct val="112000"/>
+              </a:lnSpc>
+            </a:pPr>
+            <a:r>
+              <a:rPr sz="2000" b="0">
+                <a:solidFill>
+                  <a:srgbClr val="F5F7FA"/>
+                </a:solidFill>
+                <a:latin typeface="Arial"/>
+              </a:rPr>
+              <a:t/>
+            </a:r>
+          </a:p>
+          <a:p>
+            <a:pPr algn="l">
+              <a:lnSpc>
+                <a:spcPct val="112000"/>
+              </a:lnSpc>
+            </a:pPr>
+            <a:r>
+              <a:rPr sz="2200" b="0">
+                <a:solidFill>
+                  <a:srgbClr val="F5F7FA"/>
+                </a:solidFill>
+                <a:latin typeface="Arial"/>
+              </a:rPr>
+              <a:t>value  -&gt;  norms  -&gt;  requirements  -&gt;  features  -&gt;  </a:t>
+            </a:r>
+            <a:r>
+              <a:rPr sz="2200" b="1">
+                <a:solidFill>
+                  <a:srgbClr val="00FF41"/>
+                </a:solidFill>
+                <a:latin typeface="Arial"/>
+              </a:rPr>
+              <a:t>the prompts you run tomorrow</a:t>
+            </a:r>
+          </a:p>
+          <a:p>
+            <a:pPr algn="l">
+              <a:lnSpc>
+                <a:spcPct val="112000"/>
+              </a:lnSpc>
+            </a:pPr>
+            <a:r>
+              <a:rPr sz="2000" b="0">
+                <a:solidFill>
+                  <a:srgbClr val="F5F7FA"/>
+                </a:solidFill>
+                <a:latin typeface="Arial"/>
+              </a:rPr>
+              <a:t/>
+            </a:r>
+          </a:p>
+          <a:p>
+            <a:pPr algn="l">
+              <a:lnSpc>
+                <a:spcPct val="112000"/>
+              </a:lnSpc>
+            </a:pPr>
+            <a:r>
+              <a:rPr sz="1700" b="0">
+                <a:solidFill>
+                  <a:srgbClr val="8A94A6"/>
+                </a:solidFill>
+                <a:latin typeface="Arial"/>
+              </a:rPr>
+              <a:t>The bottom of the tree IS your Thursday build plan - the exact prompts, grounded in the value.</a:t>
+            </a:r>
+          </a:p>
+        </p:txBody>
+      </p:sp>
+      <p:sp>
+        <p:nvSpPr>
+          <p:cNvPr id="6" name="TextBox 5"/>
+          <p:cNvSpPr txBox="1"/>
+          <p:nvPr/>
+        </p:nvSpPr>
+        <p:spPr>
+          <a:xfrm>
+            <a:off x="640080" y="6355080"/>
+            <a:ext cx="10972800" cy="365760"/>
+          </a:xfrm>
+          <a:prstGeom prst="rect">
+            <a:avLst/>
+          </a:prstGeom>
+          <a:noFill/>
+        </p:spPr>
+        <p:txBody>
+          <a:bodyPr wrap="square" anchor="t">
+            <a:spAutoFit/>
+          </a:bodyPr>
+          <a:lstStyle/>
+          <a:p>
+            <a:pPr algn="l">
+              <a:lnSpc>
+                <a:spcPct val="100000"/>
+              </a:lnSpc>
+            </a:pPr>
+            <a:r>
+              <a:rPr sz="1000" b="0">
+                <a:solidFill>
+                  <a:srgbClr val="5A6474"/>
+                </a:solidFill>
+                <a:latin typeface="Courier New"/>
+              </a:rPr>
+              <a:t>Good Code, Good Vibes · TECHIE 1121 · Cornell Tech · Summer 2026</a:t>
+            </a:r>
+          </a:p>
+        </p:txBody>
+      </p:sp>
+    </p:spTree>
+  </p:cSld>
+  <p:clrMapOvr>
+    <a:masterClrMapping/>
+  </p:clrMapOvr>
+</p:sld>
+</file>
+
+<file path=ppt/slides/slide11.xml><?xml version="1.0" encoding="utf-8"?>
+<p:sld xmlns:a="http://schemas.openxmlformats.org/drawingml/2006/main" xmlns:p="http://schemas.openxmlformats.org/presentationml/2006/main" xmlns:r="http://schemas.openxmlformats.org/officeDocument/2006/relationships">
+  <p:cSld>
+    <p:bg>
+      <p:bgPr>
+        <a:solidFill>
+          <a:srgbClr val="0B0E14"/>
+        </a:solidFill>
+        <a:effectLst/>
+      </p:bgPr>
+    </p:bg>
+    <p:spTree>
+      <p:nvGrpSpPr>
+        <p:cNvPr id="1" name=""/>
+        <p:cNvGrpSpPr/>
+        <p:nvPr/>
+      </p:nvGrpSpPr>
+      <p:grpSpPr/>
+      <p:sp>
+        <p:nvSpPr>
+          <p:cNvPr id="2" name="TextBox 1"/>
+          <p:cNvSpPr txBox="1"/>
+          <p:nvPr/>
+        </p:nvSpPr>
+        <p:spPr>
+          <a:xfrm>
+            <a:off x="640080" y="502920"/>
+            <a:ext cx="10058400" cy="365760"/>
+          </a:xfrm>
+          <a:prstGeom prst="rect">
+            <a:avLst/>
+          </a:prstGeom>
+          <a:noFill/>
+        </p:spPr>
+        <p:txBody>
+          <a:bodyPr wrap="square" anchor="t">
+            <a:spAutoFit/>
+          </a:bodyPr>
+          <a:lstStyle/>
+          <a:p>
+            <a:pPr algn="l">
+              <a:lnSpc>
+                <a:spcPct val="100000"/>
+              </a:lnSpc>
+            </a:pPr>
+            <a:r>
+              <a:rPr sz="1300" b="1">
+                <a:solidFill>
+                  <a:srgbClr val="00FF41"/>
+                </a:solidFill>
+                <a:latin typeface="Courier New"/>
+              </a:rPr>
+              <a:t>STORYBOARD IT</a:t>
+            </a:r>
+          </a:p>
+        </p:txBody>
+      </p:sp>
+      <p:sp>
+        <p:nvSpPr>
+          <p:cNvPr id="3" name="Rectangle 2"/>
+          <p:cNvSpPr/>
+          <p:nvPr/>
+        </p:nvSpPr>
+        <p:spPr>
+          <a:xfrm>
+            <a:off x="640080" y="932688"/>
+            <a:ext cx="822960" cy="73152"/>
+          </a:xfrm>
+          <a:prstGeom prst="rect">
+            <a:avLst/>
+          </a:prstGeom>
+          <a:solidFill>
+            <a:srgbClr val="00FF41"/>
+          </a:solidFill>
+          <a:ln>
+            <a:noFill/>
+          </a:ln>
+          <a:effectLst/>
+        </p:spPr>
+        <p:style>
+          <a:lnRef idx="1">
+            <a:schemeClr val="accent1"/>
+          </a:lnRef>
+          <a:fillRef idx="3">
+            <a:schemeClr val="accent1"/>
+          </a:fillRef>
+          <a:effectRef idx="2">
+            <a:schemeClr val="accent1"/>
+          </a:effectRef>
+          <a:fontRef idx="minor">
+            <a:schemeClr val="lt1"/>
+          </a:fontRef>
+        </p:style>
+        <p:txBody>
+          <a:bodyPr rtlCol="0" anchor="ctr"/>
+          <a:lstStyle/>
+          <a:p>
+            <a:pPr algn="ctr"/>
+          </a:p>
+        </p:txBody>
+      </p:sp>
+      <p:sp>
+        <p:nvSpPr>
+          <p:cNvPr id="4" name="TextBox 3"/>
+          <p:cNvSpPr txBox="1"/>
+          <p:nvPr/>
+        </p:nvSpPr>
+        <p:spPr>
+          <a:xfrm>
+            <a:off x="640080" y="1188720"/>
+            <a:ext cx="10972800" cy="1097280"/>
+          </a:xfrm>
+          <a:prstGeom prst="rect">
+            <a:avLst/>
+          </a:prstGeom>
+          <a:noFill/>
+        </p:spPr>
+        <p:txBody>
+          <a:bodyPr wrap="square" anchor="t">
+            <a:spAutoFit/>
+          </a:bodyPr>
+          <a:lstStyle/>
+          <a:p>
+            <a:pPr algn="l">
+              <a:lnSpc>
+                <a:spcPct val="100000"/>
+              </a:lnSpc>
+            </a:pPr>
+            <a:r>
+              <a:rPr sz="3400" b="1">
+                <a:solidFill>
+                  <a:srgbClr val="F5F7FA"/>
+                </a:solidFill>
+                <a:latin typeface="Arial"/>
+              </a:rPr>
+              <a:t>4-8 frames: the value in use</a:t>
+            </a:r>
+          </a:p>
+        </p:txBody>
+      </p:sp>
+      <p:sp>
+        <p:nvSpPr>
+          <p:cNvPr id="5" name="TextBox 4"/>
+          <p:cNvSpPr txBox="1"/>
+          <p:nvPr/>
+        </p:nvSpPr>
+        <p:spPr>
+          <a:xfrm>
+            <a:off x="658368" y="2286000"/>
+            <a:ext cx="10881360" cy="3657600"/>
+          </a:xfrm>
+          <a:prstGeom prst="rect">
+            <a:avLst/>
+          </a:prstGeom>
+          <a:noFill/>
+        </p:spPr>
+        <p:txBody>
+          <a:bodyPr wrap="square" anchor="t">
+            <a:spAutoFit/>
+          </a:bodyPr>
+          <a:lstStyle/>
+          <a:p>
+            <a:pPr algn="l">
+              <a:lnSpc>
+                <a:spcPct val="112000"/>
+              </a:lnSpc>
+            </a:pPr>
+            <a:r>
+              <a:rPr sz="2000" b="1">
+                <a:solidFill>
+                  <a:srgbClr val="00FF41"/>
+                </a:solidFill>
+                <a:latin typeface="Arial"/>
+              </a:rPr>
+              <a:t>•  </a:t>
+            </a:r>
+            <a:r>
+              <a:rPr sz="2000" b="0">
+                <a:solidFill>
+                  <a:srgbClr val="F5F7FA"/>
+                </a:solidFill>
+                <a:latin typeface="Arial"/>
+              </a:rPr>
+              <a:t>Frame the user, their problem, where your thing enters, and what changes.</a:t>
+            </a:r>
+          </a:p>
+          <a:p>
+            <a:pPr algn="l">
+              <a:lnSpc>
+                <a:spcPct val="112000"/>
+              </a:lnSpc>
+            </a:pPr>
+            <a:r>
+              <a:rPr sz="2000" b="1">
+                <a:solidFill>
+                  <a:srgbClr val="00FF41"/>
+                </a:solidFill>
+                <a:latin typeface="Arial"/>
+              </a:rPr>
+              <a:t>•  </a:t>
+            </a:r>
+            <a:r>
+              <a:rPr sz="2000" b="0">
+                <a:solidFill>
+                  <a:srgbClr val="F5F7FA"/>
+                </a:solidFill>
+                <a:latin typeface="Arial"/>
+              </a:rPr>
+              <a:t>Hand-drawn (photograph it) or AI-assisted - rough is fine.</a:t>
+            </a:r>
+          </a:p>
+          <a:p>
+            <a:pPr algn="l">
+              <a:lnSpc>
+                <a:spcPct val="112000"/>
+              </a:lnSpc>
+            </a:pPr>
+            <a:r>
+              <a:rPr sz="2000" b="1">
+                <a:solidFill>
+                  <a:srgbClr val="00FF41"/>
+                </a:solidFill>
+                <a:latin typeface="Arial"/>
+              </a:rPr>
+              <a:t>•  </a:t>
+            </a:r>
+            <a:r>
+              <a:rPr sz="2000" b="0">
+                <a:solidFill>
+                  <a:srgbClr val="F5F7FA"/>
+                </a:solidFill>
+                <a:latin typeface="Arial"/>
+              </a:rPr>
+              <a:t>It doubles as your Thursday pitch skeleton.</a:t>
+            </a:r>
+          </a:p>
+          <a:p>
+            <a:pPr algn="l">
+              <a:lnSpc>
+                <a:spcPct val="112000"/>
+              </a:lnSpc>
+            </a:pPr>
+            <a:r>
+              <a:rPr sz="2000" b="1">
+                <a:solidFill>
+                  <a:srgbClr val="00FF41"/>
+                </a:solidFill>
+                <a:latin typeface="Arial"/>
+              </a:rPr>
+              <a:t>•  </a:t>
+            </a:r>
+            <a:r>
+              <a:rPr sz="2000" b="0">
+                <a:solidFill>
+                  <a:srgbClr val="F5F7FA"/>
+                </a:solidFill>
+                <a:latin typeface="Arial"/>
+              </a:rPr>
+              <a:t>Show the value living in the design, not just in the copy.</a:t>
+            </a:r>
+          </a:p>
+        </p:txBody>
+      </p:sp>
+      <p:sp>
+        <p:nvSpPr>
+          <p:cNvPr id="6" name="TextBox 5"/>
+          <p:cNvSpPr txBox="1"/>
+          <p:nvPr/>
+        </p:nvSpPr>
+        <p:spPr>
+          <a:xfrm>
+            <a:off x="640080" y="6355080"/>
+            <a:ext cx="10972800" cy="365760"/>
+          </a:xfrm>
+          <a:prstGeom prst="rect">
+            <a:avLst/>
+          </a:prstGeom>
+          <a:noFill/>
+        </p:spPr>
+        <p:txBody>
+          <a:bodyPr wrap="square" anchor="t">
+            <a:spAutoFit/>
+          </a:bodyPr>
+          <a:lstStyle/>
+          <a:p>
+            <a:pPr algn="l">
+              <a:lnSpc>
+                <a:spcPct val="100000"/>
+              </a:lnSpc>
+            </a:pPr>
+            <a:r>
+              <a:rPr sz="1000" b="0">
+                <a:solidFill>
+                  <a:srgbClr val="5A6474"/>
+                </a:solidFill>
+                <a:latin typeface="Courier New"/>
+              </a:rPr>
+              <a:t>Good Code, Good Vibes · TECHIE 1121 · Cornell Tech · Summer 2026</a:t>
+            </a:r>
+          </a:p>
+        </p:txBody>
+      </p:sp>
+    </p:spTree>
+  </p:cSld>
+  <p:clrMapOvr>
+    <a:masterClrMapping/>
+  </p:clrMapOvr>
+</p:sld>
+</file>
+
+<file path=ppt/slides/slide12.xml><?xml version="1.0" encoding="utf-8"?>
+<p:sld xmlns:a="http://schemas.openxmlformats.org/drawingml/2006/main" xmlns:p="http://schemas.openxmlformats.org/presentationml/2006/main" xmlns:r="http://schemas.openxmlformats.org/officeDocument/2006/relationships">
+  <p:cSld>
+    <p:bg>
+      <p:bgPr>
+        <a:solidFill>
+          <a:srgbClr val="0B0E14"/>
+        </a:solidFill>
+        <a:effectLst/>
+      </p:bgPr>
+    </p:bg>
+    <p:spTree>
+      <p:nvGrpSpPr>
+        <p:cNvPr id="1" name=""/>
+        <p:cNvGrpSpPr/>
+        <p:nvPr/>
+      </p:nvGrpSpPr>
+      <p:grpSpPr/>
+      <p:sp>
+        <p:nvSpPr>
+          <p:cNvPr id="2" name="TextBox 1"/>
+          <p:cNvSpPr txBox="1"/>
+          <p:nvPr/>
+        </p:nvSpPr>
+        <p:spPr>
+          <a:xfrm>
+            <a:off x="640080" y="502920"/>
+            <a:ext cx="10058400" cy="365760"/>
+          </a:xfrm>
+          <a:prstGeom prst="rect">
+            <a:avLst/>
+          </a:prstGeom>
+          <a:noFill/>
+        </p:spPr>
+        <p:txBody>
+          <a:bodyPr wrap="square" anchor="t">
+            <a:spAutoFit/>
+          </a:bodyPr>
+          <a:lstStyle/>
+          <a:p>
+            <a:pPr algn="l">
+              <a:lnSpc>
+                <a:spcPct val="100000"/>
+              </a:lnSpc>
+            </a:pPr>
+            <a:r>
+              <a:rPr sz="1300" b="1">
+                <a:solidFill>
+                  <a:srgbClr val="00FF41"/>
+                </a:solidFill>
+                <a:latin typeface="Courier New"/>
+              </a:rPr>
+              <a:t>TOOLS FOR TODAY</a:t>
+            </a:r>
+          </a:p>
+        </p:txBody>
+      </p:sp>
+      <p:sp>
+        <p:nvSpPr>
+          <p:cNvPr id="3" name="Rectangle 2"/>
+          <p:cNvSpPr/>
+          <p:nvPr/>
+        </p:nvSpPr>
+        <p:spPr>
+          <a:xfrm>
+            <a:off x="640080" y="932688"/>
+            <a:ext cx="822960" cy="73152"/>
+          </a:xfrm>
+          <a:prstGeom prst="rect">
+            <a:avLst/>
+          </a:prstGeom>
+          <a:solidFill>
+            <a:srgbClr val="00FF41"/>
+          </a:solidFill>
+          <a:ln>
+            <a:noFill/>
+          </a:ln>
+          <a:effectLst/>
+        </p:spPr>
+        <p:style>
+          <a:lnRef idx="1">
+            <a:schemeClr val="accent1"/>
+          </a:lnRef>
+          <a:fillRef idx="3">
+            <a:schemeClr val="accent1"/>
+          </a:fillRef>
+          <a:effectRef idx="2">
+            <a:schemeClr val="accent1"/>
+          </a:effectRef>
+          <a:fontRef idx="minor">
+            <a:schemeClr val="lt1"/>
+          </a:fontRef>
+        </p:style>
+        <p:txBody>
+          <a:bodyPr rtlCol="0" anchor="ctr"/>
+          <a:lstStyle/>
+          <a:p>
+            <a:pPr algn="ctr"/>
+          </a:p>
+        </p:txBody>
+      </p:sp>
+      <p:sp>
+        <p:nvSpPr>
+          <p:cNvPr id="4" name="TextBox 3"/>
+          <p:cNvSpPr txBox="1"/>
+          <p:nvPr/>
+        </p:nvSpPr>
+        <p:spPr>
+          <a:xfrm>
+            <a:off x="640080" y="1188720"/>
+            <a:ext cx="10972800" cy="1097280"/>
+          </a:xfrm>
+          <a:prstGeom prst="rect">
+            <a:avLst/>
+          </a:prstGeom>
+          <a:noFill/>
+        </p:spPr>
+        <p:txBody>
+          <a:bodyPr wrap="square" anchor="t">
+            <a:spAutoFit/>
+          </a:bodyPr>
+          <a:lstStyle/>
+          <a:p>
+            <a:pPr algn="l">
+              <a:lnSpc>
+                <a:spcPct val="100000"/>
+              </a:lnSpc>
+            </a:pPr>
+            <a:r>
+              <a:rPr sz="3400" b="1">
+                <a:solidFill>
+                  <a:srgbClr val="F5F7FA"/>
+                </a:solidFill>
+                <a:latin typeface="Arial"/>
+              </a:rPr>
+              <a:t>Storyboard + pitch</a:t>
+            </a:r>
+          </a:p>
+        </p:txBody>
+      </p:sp>
+      <p:sp>
+        <p:nvSpPr>
+          <p:cNvPr id="5" name="TextBox 4"/>
+          <p:cNvSpPr txBox="1"/>
+          <p:nvPr/>
+        </p:nvSpPr>
+        <p:spPr>
+          <a:xfrm>
+            <a:off x="658368" y="2286000"/>
+            <a:ext cx="10881360" cy="3657600"/>
+          </a:xfrm>
+          <a:prstGeom prst="rect">
+            <a:avLst/>
+          </a:prstGeom>
+          <a:noFill/>
+        </p:spPr>
+        <p:txBody>
+          <a:bodyPr wrap="square" anchor="t">
+            <a:spAutoFit/>
+          </a:bodyPr>
+          <a:lstStyle/>
+          <a:p>
+            <a:pPr algn="l">
+              <a:lnSpc>
+                <a:spcPct val="112000"/>
+              </a:lnSpc>
+            </a:pPr>
+            <a:r>
+              <a:rPr sz="2000" b="1">
+                <a:solidFill>
+                  <a:srgbClr val="00FF41"/>
+                </a:solidFill>
+                <a:latin typeface="Arial"/>
+              </a:rPr>
+              <a:t>•  </a:t>
+            </a:r>
+            <a:r>
+              <a:rPr sz="2000" b="0">
+                <a:solidFill>
+                  <a:srgbClr val="F5F7FA"/>
+                </a:solidFill>
+                <a:latin typeface="Arial"/>
+              </a:rPr>
+              <a:t>Storyboard: FigJam / Figma, Canva, Google Slides (one frame per slide), or Storyboarder (free &amp; open-source).</a:t>
+            </a:r>
+          </a:p>
+          <a:p>
+            <a:pPr algn="l">
+              <a:lnSpc>
+                <a:spcPct val="112000"/>
+              </a:lnSpc>
+            </a:pPr>
+            <a:r>
+              <a:rPr sz="2000" b="1">
+                <a:solidFill>
+                  <a:srgbClr val="00FF41"/>
+                </a:solidFill>
+                <a:latin typeface="Arial"/>
+              </a:rPr>
+              <a:t>•  </a:t>
+            </a:r>
+            <a:r>
+              <a:rPr sz="2000" b="0">
+                <a:solidFill>
+                  <a:srgbClr val="F5F7FA"/>
+                </a:solidFill>
+                <a:latin typeface="Arial"/>
+              </a:rPr>
+              <a:t>AI pitch video (for Thursday): Google Veo 3.1 (in Flow), Runway, Kling, or Pika.</a:t>
+            </a:r>
+          </a:p>
+          <a:p>
+            <a:pPr algn="l">
+              <a:lnSpc>
+                <a:spcPct val="112000"/>
+              </a:lnSpc>
+            </a:pPr>
+            <a:r>
+              <a:rPr sz="2000" b="1">
+                <a:solidFill>
+                  <a:srgbClr val="00FF41"/>
+                </a:solidFill>
+                <a:latin typeface="Arial"/>
+              </a:rPr>
+              <a:t>•  </a:t>
+            </a:r>
+            <a:r>
+              <a:rPr sz="2000" b="0">
+                <a:solidFill>
+                  <a:srgbClr val="F5F7FA"/>
+                </a:solidFill>
+                <a:latin typeface="Arial"/>
+              </a:rPr>
+              <a:t>Note: OpenAI retired the Sora app in April 2026 - use Veo / Runway / Kling / Pika instead.</a:t>
+            </a:r>
+          </a:p>
+          <a:p>
+            <a:pPr algn="l">
+              <a:lnSpc>
+                <a:spcPct val="112000"/>
+              </a:lnSpc>
+            </a:pPr>
+            <a:r>
+              <a:rPr sz="2000" b="1">
+                <a:solidFill>
+                  <a:srgbClr val="00FF41"/>
+                </a:solidFill>
+                <a:latin typeface="Arial"/>
+              </a:rPr>
+              <a:t>•  </a:t>
+            </a:r>
+            <a:r>
+              <a:rPr sz="2000" b="0">
+                <a:solidFill>
+                  <a:srgbClr val="F5F7FA"/>
+                </a:solidFill>
+                <a:latin typeface="Arial"/>
+              </a:rPr>
+              <a:t>Free tiers add watermarks + limits - fine for a class pitch.</a:t>
+            </a:r>
+          </a:p>
+          <a:p>
+            <a:pPr algn="l">
+              <a:lnSpc>
+                <a:spcPct val="112000"/>
+              </a:lnSpc>
+            </a:pPr>
+            <a:r>
+              <a:rPr sz="2000" b="1">
+                <a:solidFill>
+                  <a:srgbClr val="00FF41"/>
+                </a:solidFill>
+                <a:latin typeface="Arial"/>
+              </a:rPr>
+              <a:t>•  </a:t>
+            </a:r>
+            <a:r>
+              <a:rPr sz="2000" b="0">
+                <a:solidFill>
+                  <a:srgbClr val="F5F7FA"/>
+                </a:solidFill>
+                <a:latin typeface="Arial"/>
+              </a:rPr>
+              <a:t>Interview + persona: just talk to a person; capture notes in FigJam or a doc.</a:t>
+            </a:r>
+          </a:p>
+        </p:txBody>
+      </p:sp>
+      <p:sp>
+        <p:nvSpPr>
+          <p:cNvPr id="6" name="TextBox 5"/>
+          <p:cNvSpPr txBox="1"/>
+          <p:nvPr/>
+        </p:nvSpPr>
+        <p:spPr>
+          <a:xfrm>
+            <a:off x="640080" y="6355080"/>
+            <a:ext cx="10972800" cy="365760"/>
+          </a:xfrm>
+          <a:prstGeom prst="rect">
+            <a:avLst/>
+          </a:prstGeom>
+          <a:noFill/>
+        </p:spPr>
+        <p:txBody>
+          <a:bodyPr wrap="square" anchor="t">
+            <a:spAutoFit/>
+          </a:bodyPr>
+          <a:lstStyle/>
+          <a:p>
+            <a:pPr algn="l">
+              <a:lnSpc>
+                <a:spcPct val="100000"/>
+              </a:lnSpc>
+            </a:pPr>
+            <a:r>
+              <a:rPr sz="1000" b="0">
+                <a:solidFill>
+                  <a:srgbClr val="5A6474"/>
+                </a:solidFill>
+                <a:latin typeface="Courier New"/>
+              </a:rPr>
+              <a:t>Good Code, Good Vibes · TECHIE 1121 · Cornell Tech · Summer 2026</a:t>
+            </a:r>
+          </a:p>
+        </p:txBody>
+      </p:sp>
+    </p:spTree>
+  </p:cSld>
+  <p:clrMapOvr>
+    <a:masterClrMapping/>
+  </p:clrMapOvr>
+</p:sld>
+</file>
+
+<file path=ppt/slides/slide13.xml><?xml version="1.0" encoding="utf-8"?>
+<p:sld xmlns:a="http://schemas.openxmlformats.org/drawingml/2006/main" xmlns:p="http://schemas.openxmlformats.org/presentationml/2006/main" xmlns:r="http://schemas.openxmlformats.org/officeDocument/2006/relationships">
+  <p:cSld>
+    <p:bg>
+      <p:bgPr>
+        <a:solidFill>
+          <a:srgbClr val="0B0E14"/>
+        </a:solidFill>
+        <a:effectLst/>
+      </p:bgPr>
+    </p:bg>
+    <p:spTree>
+      <p:nvGrpSpPr>
+        <p:cNvPr id="1" name=""/>
+        <p:cNvGrpSpPr/>
+        <p:nvPr/>
+      </p:nvGrpSpPr>
+      <p:grpSpPr/>
+      <p:sp>
+        <p:nvSpPr>
+          <p:cNvPr id="2" name="TextBox 1"/>
+          <p:cNvSpPr txBox="1"/>
+          <p:nvPr/>
+        </p:nvSpPr>
+        <p:spPr>
+          <a:xfrm>
+            <a:off x="640080" y="502920"/>
+            <a:ext cx="10058400" cy="365760"/>
+          </a:xfrm>
+          <a:prstGeom prst="rect">
+            <a:avLst/>
+          </a:prstGeom>
+          <a:noFill/>
+        </p:spPr>
+        <p:txBody>
+          <a:bodyPr wrap="square" anchor="t">
+            <a:spAutoFit/>
+          </a:bodyPr>
+          <a:lstStyle/>
+          <a:p>
+            <a:pPr algn="l">
+              <a:lnSpc>
+                <a:spcPct val="100000"/>
+              </a:lnSpc>
+            </a:pPr>
+            <a:r>
+              <a:rPr sz="1300" b="1">
+                <a:solidFill>
+                  <a:srgbClr val="00FF41"/>
+                </a:solidFill>
+                <a:latin typeface="Courier New"/>
+              </a:rPr>
+              <a:t>SCREENSHOT SLOT</a:t>
+            </a:r>
+          </a:p>
+        </p:txBody>
+      </p:sp>
+      <p:sp>
+        <p:nvSpPr>
+          <p:cNvPr id="3" name="Rectangle 2"/>
+          <p:cNvSpPr/>
+          <p:nvPr/>
+        </p:nvSpPr>
+        <p:spPr>
+          <a:xfrm>
+            <a:off x="640080" y="932688"/>
+            <a:ext cx="822960" cy="73152"/>
+          </a:xfrm>
+          <a:prstGeom prst="rect">
+            <a:avLst/>
+          </a:prstGeom>
+          <a:solidFill>
+            <a:srgbClr val="00FF41"/>
+          </a:solidFill>
+          <a:ln>
+            <a:noFill/>
+          </a:ln>
+          <a:effectLst/>
+        </p:spPr>
+        <p:style>
+          <a:lnRef idx="1">
+            <a:schemeClr val="accent1"/>
+          </a:lnRef>
+          <a:fillRef idx="3">
+            <a:schemeClr val="accent1"/>
+          </a:fillRef>
+          <a:effectRef idx="2">
+            <a:schemeClr val="accent1"/>
+          </a:effectRef>
+          <a:fontRef idx="minor">
+            <a:schemeClr val="lt1"/>
+          </a:fontRef>
+        </p:style>
+        <p:txBody>
+          <a:bodyPr rtlCol="0" anchor="ctr"/>
+          <a:lstStyle/>
+          <a:p>
+            <a:pPr algn="ctr"/>
+          </a:p>
+        </p:txBody>
+      </p:sp>
+      <p:sp>
+        <p:nvSpPr>
+          <p:cNvPr id="4" name="TextBox 3"/>
+          <p:cNvSpPr txBox="1"/>
+          <p:nvPr/>
+        </p:nvSpPr>
+        <p:spPr>
+          <a:xfrm>
+            <a:off x="640080" y="1188720"/>
+            <a:ext cx="10972800" cy="914400"/>
+          </a:xfrm>
+          <a:prstGeom prst="rect">
+            <a:avLst/>
+          </a:prstGeom>
+          <a:noFill/>
+        </p:spPr>
+        <p:txBody>
+          <a:bodyPr wrap="square" anchor="t">
+            <a:spAutoFit/>
+          </a:bodyPr>
+          <a:lstStyle/>
+          <a:p>
+            <a:pPr algn="l">
+              <a:lnSpc>
+                <a:spcPct val="100000"/>
+              </a:lnSpc>
+            </a:pPr>
+            <a:r>
+              <a:rPr sz="3000" b="1">
+                <a:solidFill>
+                  <a:srgbClr val="F5F7FA"/>
+                </a:solidFill>
+                <a:latin typeface="Arial"/>
+              </a:rPr>
+              <a:t>Show an example</a:t>
+            </a:r>
+          </a:p>
+        </p:txBody>
+      </p:sp>
+      <p:sp>
+        <p:nvSpPr>
+          <p:cNvPr id="5" name="Rounded Rectangle 4"/>
+          <p:cNvSpPr/>
+          <p:nvPr/>
+        </p:nvSpPr>
+        <p:spPr>
+          <a:xfrm>
+            <a:off x="2194560" y="2331720"/>
+            <a:ext cx="7772400" cy="3566160"/>
+          </a:xfrm>
+          <a:prstGeom prst="roundRect">
+            <a:avLst/>
+          </a:prstGeom>
+          <a:solidFill>
+            <a:srgbClr val="151B26"/>
+          </a:solidFill>
+          <a:ln w="19050">
+            <a:solidFill>
+              <a:srgbClr val="00FF41"/>
+            </a:solidFill>
+            <a:prstDash val="dash"/>
+          </a:ln>
+          <a:effectLst/>
+        </p:spPr>
+        <p:style>
+          <a:lnRef idx="1">
+            <a:schemeClr val="accent1"/>
+          </a:lnRef>
+          <a:fillRef idx="3">
+            <a:schemeClr val="accent1"/>
+          </a:fillRef>
+          <a:effectRef idx="2">
+            <a:schemeClr val="accent1"/>
+          </a:effectRef>
+          <a:fontRef idx="minor">
+            <a:schemeClr val="lt1"/>
+          </a:fontRef>
+        </p:style>
+        <p:txBody>
+          <a:bodyPr rtlCol="0" anchor="ctr"/>
+          <a:lstStyle/>
+          <a:p>
+            <a:pPr algn="ctr"/>
+          </a:p>
+        </p:txBody>
+      </p:sp>
+      <p:sp>
+        <p:nvSpPr>
+          <p:cNvPr id="6" name="TextBox 5"/>
+          <p:cNvSpPr txBox="1"/>
+          <p:nvPr/>
+        </p:nvSpPr>
+        <p:spPr>
+          <a:xfrm>
+            <a:off x="2194560" y="3383280"/>
+            <a:ext cx="7772400" cy="731520"/>
+          </a:xfrm>
+          <a:prstGeom prst="rect">
+            <a:avLst/>
+          </a:prstGeom>
+          <a:noFill/>
+        </p:spPr>
+        <p:txBody>
+          <a:bodyPr wrap="square" anchor="t">
+            <a:spAutoFit/>
+          </a:bodyPr>
+          <a:lstStyle/>
+          <a:p>
+            <a:pPr algn="ctr">
+              <a:lnSpc>
+                <a:spcPct val="100000"/>
+              </a:lnSpc>
+            </a:pPr>
+            <a:r>
+              <a:rPr sz="2200" b="1">
+                <a:solidFill>
+                  <a:srgbClr val="00FF41"/>
+                </a:solidFill>
+                <a:latin typeface="Courier New"/>
+              </a:rPr>
+              <a:t>[ example storyboard or persona goes here ]</a:t>
+            </a:r>
+          </a:p>
+        </p:txBody>
+      </p:sp>
+      <p:sp>
+        <p:nvSpPr>
+          <p:cNvPr id="7" name="TextBox 6"/>
+          <p:cNvSpPr txBox="1"/>
+          <p:nvPr/>
+        </p:nvSpPr>
+        <p:spPr>
+          <a:xfrm>
+            <a:off x="2194560" y="4114800"/>
+            <a:ext cx="7772400" cy="731520"/>
+          </a:xfrm>
+          <a:prstGeom prst="rect">
+            <a:avLst/>
+          </a:prstGeom>
+          <a:noFill/>
+        </p:spPr>
+        <p:txBody>
+          <a:bodyPr wrap="square" anchor="t">
+            <a:spAutoFit/>
+          </a:bodyPr>
+          <a:lstStyle/>
+          <a:p>
+            <a:pPr algn="ctr">
+              <a:lnSpc>
+                <a:spcPct val="100000"/>
+              </a:lnSpc>
+            </a:pPr>
+            <a:r>
+              <a:rPr sz="1400" b="0">
+                <a:solidFill>
+                  <a:srgbClr val="8A94A6"/>
+                </a:solidFill>
+                <a:latin typeface="Arial"/>
+              </a:rPr>
+              <a:t>a strong persona, a storyboard, or an AI-pitch still</a:t>
+            </a:r>
+          </a:p>
+        </p:txBody>
+      </p:sp>
+      <p:sp>
+        <p:nvSpPr>
+          <p:cNvPr id="8" name="TextBox 7"/>
+          <p:cNvSpPr txBox="1"/>
+          <p:nvPr/>
+        </p:nvSpPr>
+        <p:spPr>
+          <a:xfrm>
+            <a:off x="640080" y="6355080"/>
+            <a:ext cx="10972800" cy="365760"/>
+          </a:xfrm>
+          <a:prstGeom prst="rect">
+            <a:avLst/>
+          </a:prstGeom>
+          <a:noFill/>
+        </p:spPr>
+        <p:txBody>
+          <a:bodyPr wrap="square" anchor="t">
+            <a:spAutoFit/>
+          </a:bodyPr>
+          <a:lstStyle/>
+          <a:p>
+            <a:pPr algn="l">
+              <a:lnSpc>
+                <a:spcPct val="100000"/>
+              </a:lnSpc>
+            </a:pPr>
+            <a:r>
+              <a:rPr sz="1000" b="0">
+                <a:solidFill>
+                  <a:srgbClr val="5A6474"/>
+                </a:solidFill>
+                <a:latin typeface="Courier New"/>
+              </a:rPr>
+              <a:t>Good Code, Good Vibes · TECHIE 1121 · Cornell Tech · Summer 2026</a:t>
+            </a:r>
+          </a:p>
+        </p:txBody>
+      </p:sp>
+    </p:spTree>
+  </p:cSld>
+  <p:clrMapOvr>
+    <a:masterClrMapping/>
+  </p:clrMapOvr>
+</p:sld>
+</file>
+
+<file path=ppt/slides/slide14.xml><?xml version="1.0" encoding="utf-8"?>
+<p:sld xmlns:a="http://schemas.openxmlformats.org/drawingml/2006/main" xmlns:p="http://schemas.openxmlformats.org/presentationml/2006/main" xmlns:r="http://schemas.openxmlformats.org/officeDocument/2006/relationships">
+  <p:cSld>
+    <p:bg>
+      <p:bgPr>
+        <a:solidFill>
+          <a:srgbClr val="0B0E14"/>
+        </a:solidFill>
+        <a:effectLst/>
+      </p:bgPr>
+    </p:bg>
+    <p:spTree>
+      <p:nvGrpSpPr>
+        <p:cNvPr id="1" name=""/>
+        <p:cNvGrpSpPr/>
+        <p:nvPr/>
+      </p:nvGrpSpPr>
+      <p:grpSpPr/>
+      <p:sp>
+        <p:nvSpPr>
+          <p:cNvPr id="2" name="TextBox 1"/>
+          <p:cNvSpPr txBox="1"/>
+          <p:nvPr/>
+        </p:nvSpPr>
+        <p:spPr>
+          <a:xfrm>
+            <a:off x="640080" y="502920"/>
+            <a:ext cx="10058400" cy="365760"/>
+          </a:xfrm>
+          <a:prstGeom prst="rect">
+            <a:avLst/>
+          </a:prstGeom>
+          <a:noFill/>
+        </p:spPr>
+        <p:txBody>
+          <a:bodyPr wrap="square" anchor="t">
+            <a:spAutoFit/>
+          </a:bodyPr>
+          <a:lstStyle/>
+          <a:p>
+            <a:pPr algn="l">
+              <a:lnSpc>
+                <a:spcPct val="100000"/>
+              </a:lnSpc>
+            </a:pPr>
+            <a:r>
+              <a:rPr sz="1300" b="1">
+                <a:solidFill>
+                  <a:srgbClr val="00FF41"/>
+                </a:solidFill>
+                <a:latin typeface="Courier New"/>
+              </a:rPr>
+              <a:t>ACTIVITY - TODAY (TEAM)</a:t>
+            </a:r>
+          </a:p>
+        </p:txBody>
+      </p:sp>
+      <p:sp>
+        <p:nvSpPr>
+          <p:cNvPr id="3" name="Rectangle 2"/>
+          <p:cNvSpPr/>
+          <p:nvPr/>
+        </p:nvSpPr>
+        <p:spPr>
+          <a:xfrm>
+            <a:off x="640080" y="932688"/>
+            <a:ext cx="822960" cy="73152"/>
+          </a:xfrm>
+          <a:prstGeom prst="rect">
+            <a:avLst/>
+          </a:prstGeom>
+          <a:solidFill>
+            <a:srgbClr val="00FF41"/>
+          </a:solidFill>
+          <a:ln>
+            <a:noFill/>
+          </a:ln>
+          <a:effectLst/>
+        </p:spPr>
+        <p:style>
+          <a:lnRef idx="1">
+            <a:schemeClr val="accent1"/>
+          </a:lnRef>
+          <a:fillRef idx="3">
+            <a:schemeClr val="accent1"/>
+          </a:fillRef>
+          <a:effectRef idx="2">
+            <a:schemeClr val="accent1"/>
+          </a:effectRef>
+          <a:fontRef idx="minor">
+            <a:schemeClr val="lt1"/>
+          </a:fontRef>
+        </p:style>
+        <p:txBody>
+          <a:bodyPr rtlCol="0" anchor="ctr"/>
+          <a:lstStyle/>
+          <a:p>
+            <a:pPr algn="ctr"/>
+          </a:p>
+        </p:txBody>
+      </p:sp>
+      <p:sp>
+        <p:nvSpPr>
+          <p:cNvPr id="4" name="TextBox 3"/>
+          <p:cNvSpPr txBox="1"/>
+          <p:nvPr/>
+        </p:nvSpPr>
+        <p:spPr>
+          <a:xfrm>
+            <a:off x="640080" y="1325880"/>
+            <a:ext cx="10972800" cy="1828800"/>
+          </a:xfrm>
+          <a:prstGeom prst="rect">
+            <a:avLst/>
+          </a:prstGeom>
+          <a:noFill/>
+        </p:spPr>
+        <p:txBody>
+          <a:bodyPr wrap="square" anchor="t">
+            <a:spAutoFit/>
+          </a:bodyPr>
+          <a:lstStyle/>
+          <a:p>
+            <a:pPr algn="l">
+              <a:lnSpc>
+                <a:spcPct val="105000"/>
+              </a:lnSpc>
+            </a:pPr>
+            <a:r>
+              <a:rPr sz="3800" b="1">
+                <a:solidFill>
+                  <a:srgbClr val="F5F7FA"/>
+                </a:solidFill>
+                <a:latin typeface="Arial"/>
+              </a:rPr>
+              <a:t>Plan the next iteration of your value.</a:t>
+            </a:r>
+          </a:p>
+        </p:txBody>
+      </p:sp>
+      <p:sp>
+        <p:nvSpPr>
+          <p:cNvPr id="5" name="TextBox 4"/>
+          <p:cNvSpPr txBox="1"/>
+          <p:nvPr/>
+        </p:nvSpPr>
+        <p:spPr>
+          <a:xfrm>
+            <a:off x="658368" y="3611880"/>
+            <a:ext cx="10972800" cy="1737360"/>
+          </a:xfrm>
+          <a:prstGeom prst="rect">
+            <a:avLst/>
+          </a:prstGeom>
+          <a:noFill/>
+        </p:spPr>
+        <p:txBody>
+          <a:bodyPr wrap="square" anchor="t">
+            <a:spAutoFit/>
+          </a:bodyPr>
+          <a:lstStyle/>
+          <a:p>
+            <a:pPr algn="l">
+              <a:lnSpc>
+                <a:spcPct val="135000"/>
+              </a:lnSpc>
+            </a:pPr>
+            <a:r>
+              <a:rPr sz="1900" b="1">
+                <a:solidFill>
+                  <a:srgbClr val="00FF41"/>
+                </a:solidFill>
+                <a:latin typeface="Arial"/>
+              </a:rPr>
+              <a:t>→  </a:t>
+            </a:r>
+            <a:r>
+              <a:rPr sz="1900" b="0">
+                <a:solidFill>
+                  <a:srgbClr val="8A94A6"/>
+                </a:solidFill>
+                <a:latin typeface="Arial"/>
+              </a:rPr>
+              <a:t>Interview a real person outside the class -&gt; build a persona + the need in their words.</a:t>
+            </a:r>
+          </a:p>
+          <a:p>
+            <a:pPr algn="l">
+              <a:lnSpc>
+                <a:spcPct val="135000"/>
+              </a:lnSpc>
+            </a:pPr>
+            <a:r>
+              <a:rPr sz="1900" b="1">
+                <a:solidFill>
+                  <a:srgbClr val="00FF41"/>
+                </a:solidFill>
+                <a:latin typeface="Arial"/>
+              </a:rPr>
+              <a:t>→  </a:t>
+            </a:r>
+            <a:r>
+              <a:rPr sz="1900" b="0">
+                <a:solidFill>
+                  <a:srgbClr val="8A94A6"/>
+                </a:solidFill>
+                <a:latin typeface="Arial"/>
+              </a:rPr>
+              <a:t>Operationalize: value -&gt; norms -&gt; requirements -&gt; features -&gt; the prompts you'll build.</a:t>
+            </a:r>
+          </a:p>
+          <a:p>
+            <a:pPr algn="l">
+              <a:lnSpc>
+                <a:spcPct val="135000"/>
+              </a:lnSpc>
+            </a:pPr>
+            <a:r>
+              <a:rPr sz="1900" b="1">
+                <a:solidFill>
+                  <a:srgbClr val="00FF41"/>
+                </a:solidFill>
+                <a:latin typeface="Arial"/>
+              </a:rPr>
+              <a:t>→  </a:t>
+            </a:r>
+            <a:r>
+              <a:rPr sz="1900" b="0">
+                <a:solidFill>
+                  <a:srgbClr val="8A94A6"/>
+                </a:solidFill>
+                <a:latin typeface="Arial"/>
+              </a:rPr>
+              <a:t>Storyboard the solution (4-8 frames) and scope the smallest real thing for Thursday.</a:t>
+            </a:r>
+          </a:p>
+        </p:txBody>
+      </p:sp>
+      <p:sp>
+        <p:nvSpPr>
+          <p:cNvPr id="6" name="Rounded Rectangle 5"/>
+          <p:cNvSpPr/>
+          <p:nvPr/>
+        </p:nvSpPr>
+        <p:spPr>
+          <a:xfrm>
+            <a:off x="640080" y="5532120"/>
+            <a:ext cx="10911535" cy="658368"/>
+          </a:xfrm>
+          <a:prstGeom prst="roundRect">
+            <a:avLst/>
+          </a:prstGeom>
+          <a:solidFill>
+            <a:srgbClr val="151B26"/>
+          </a:solidFill>
+          <a:ln w="19050">
+            <a:solidFill>
+              <a:srgbClr val="00FF41"/>
+            </a:solidFill>
+          </a:ln>
+          <a:effectLst/>
+        </p:spPr>
+        <p:style>
+          <a:lnRef idx="1">
+            <a:schemeClr val="accent1"/>
+          </a:lnRef>
+          <a:fillRef idx="3">
+            <a:schemeClr val="accent1"/>
+          </a:fillRef>
+          <a:effectRef idx="2">
+            <a:schemeClr val="accent1"/>
+          </a:effectRef>
+          <a:fontRef idx="minor">
+            <a:schemeClr val="lt1"/>
+          </a:fontRef>
+        </p:style>
+        <p:txBody>
+          <a:bodyPr rtlCol="0" anchor="ctr"/>
+          <a:lstStyle/>
+          <a:p>
+            <a:pPr algn="ctr"/>
+          </a:p>
+        </p:txBody>
+      </p:sp>
+      <p:sp>
+        <p:nvSpPr>
+          <p:cNvPr id="7" name="TextBox 6"/>
+          <p:cNvSpPr txBox="1"/>
+          <p:nvPr/>
+        </p:nvSpPr>
+        <p:spPr>
+          <a:xfrm>
+            <a:off x="914400" y="5532120"/>
+            <a:ext cx="10362895" cy="658368"/>
+          </a:xfrm>
+          <a:prstGeom prst="rect">
+            <a:avLst/>
+          </a:prstGeom>
+          <a:noFill/>
+        </p:spPr>
+        <p:txBody>
+          <a:bodyPr wrap="square" anchor="ctr">
+            <a:spAutoFit/>
+          </a:bodyPr>
+          <a:lstStyle/>
+          <a:p>
+            <a:pPr algn="l">
+              <a:lnSpc>
+                <a:spcPct val="100000"/>
+              </a:lnSpc>
+            </a:pPr>
+            <a:r>
+              <a:rPr sz="1600" b="1">
+                <a:solidFill>
+                  <a:srgbClr val="00FF41"/>
+                </a:solidFill>
+                <a:latin typeface="Arial"/>
+              </a:rPr>
+              <a:t>▶  </a:t>
+            </a:r>
+            <a:r>
+              <a:rPr sz="1600" b="1">
+                <a:solidFill>
+                  <a:srgbClr val="F5F7FA"/>
+                </a:solidFill>
+                <a:latin typeface="Arial"/>
+              </a:rPr>
+              <a:t>Deliverable = planning-report.md + your storyboard - this is Checkpoint 2 of the final</a:t>
+            </a:r>
+          </a:p>
+        </p:txBody>
+      </p:sp>
+      <p:sp>
+        <p:nvSpPr>
+          <p:cNvPr id="8" name="TextBox 7"/>
+          <p:cNvSpPr txBox="1"/>
+          <p:nvPr/>
+        </p:nvSpPr>
+        <p:spPr>
+          <a:xfrm>
+            <a:off x="640080" y="6355080"/>
+            <a:ext cx="10972800" cy="365760"/>
+          </a:xfrm>
+          <a:prstGeom prst="rect">
+            <a:avLst/>
+          </a:prstGeom>
+          <a:noFill/>
+        </p:spPr>
+        <p:txBody>
+          <a:bodyPr wrap="square" anchor="t">
+            <a:spAutoFit/>
+          </a:bodyPr>
+          <a:lstStyle/>
+          <a:p>
+            <a:pPr algn="l">
+              <a:lnSpc>
+                <a:spcPct val="100000"/>
+              </a:lnSpc>
+            </a:pPr>
+            <a:r>
+              <a:rPr sz="1000" b="0">
+                <a:solidFill>
+                  <a:srgbClr val="5A6474"/>
+                </a:solidFill>
+                <a:latin typeface="Courier New"/>
+              </a:rPr>
+              <a:t>Good Code, Good Vibes · TECHIE 1121 · Cornell Tech · Summer 2026</a:t>
+            </a:r>
+          </a:p>
+        </p:txBody>
+      </p:sp>
+    </p:spTree>
+  </p:cSld>
+  <p:clrMapOvr>
+    <a:masterClrMapping/>
+  </p:clrMapOvr>
+</p:sld>
+</file>
+
+<file path=ppt/slides/slide15.xml><?xml version="1.0" encoding="utf-8"?>
+<p:sld xmlns:a="http://schemas.openxmlformats.org/drawingml/2006/main" xmlns:p="http://schemas.openxmlformats.org/presentationml/2006/main" xmlns:r="http://schemas.openxmlformats.org/officeDocument/2006/relationships">
+  <p:cSld>
+    <p:bg>
+      <p:bgPr>
+        <a:solidFill>
+          <a:srgbClr val="0B0E14"/>
+        </a:solidFill>
+        <a:effectLst/>
+      </p:bgPr>
+    </p:bg>
+    <p:spTree>
+      <p:nvGrpSpPr>
+        <p:cNvPr id="1" name=""/>
+        <p:cNvGrpSpPr/>
+        <p:nvPr/>
+      </p:nvGrpSpPr>
+      <p:grpSpPr/>
+      <p:sp>
+        <p:nvSpPr>
+          <p:cNvPr id="2" name="TextBox 1"/>
+          <p:cNvSpPr txBox="1"/>
+          <p:nvPr/>
+        </p:nvSpPr>
+        <p:spPr>
+          <a:xfrm>
+            <a:off x="640080" y="502920"/>
+            <a:ext cx="10058400" cy="365760"/>
+          </a:xfrm>
+          <a:prstGeom prst="rect">
+            <a:avLst/>
+          </a:prstGeom>
+          <a:noFill/>
+        </p:spPr>
+        <p:txBody>
+          <a:bodyPr wrap="square" anchor="t">
+            <a:spAutoFit/>
+          </a:bodyPr>
+          <a:lstStyle/>
+          <a:p>
+            <a:pPr algn="l">
+              <a:lnSpc>
+                <a:spcPct val="100000"/>
+              </a:lnSpc>
+            </a:pPr>
+            <a:r>
+              <a:rPr sz="1300" b="1">
+                <a:solidFill>
+                  <a:srgbClr val="00FF41"/>
+                </a:solidFill>
+                <a:latin typeface="Courier New"/>
+              </a:rPr>
               <a:t>CARRY IT TO THURSDAY</a:t>
             </a:r>
           </a:p>
@@ -4393,7 +6103,7 @@
                 </a:solidFill>
                 <a:latin typeface="Arial"/>
               </a:rPr>
-              <a:t>You already have a value and Tuesday's verdict. The final is the NEXT iteration of that value - not a new theme.</a:t>
+              <a:t>You already have a value and what Tuesday's verification showed. The final is the NEXT iteration of that value - not a new theme.</a:t>
             </a:r>
           </a:p>
           <a:p>
@@ -5331,7 +7041,7 @@
                 </a:solidFill>
                 <a:latin typeface="Courier New"/>
               </a:rPr>
-              <a:t>OPERATIONALIZE - THE VALUE TREE</a:t>
+              <a:t>PERSONAS - WHY, AND THE RISK</a:t>
             </a:r>
           </a:p>
         </p:txBody>
@@ -5414,7 +7124,7 @@
                 </a:solidFill>
                 <a:latin typeface="Arial"/>
               </a:rPr>
-              <a:t>From value down to the prompts you'll build</a:t>
+              <a:t>A persona is a tool to EMPATHIZE - not to stereotype</a:t>
             </a:r>
           </a:p>
         </p:txBody>
@@ -5453,7 +7163,7 @@
                 </a:solidFill>
                 <a:latin typeface="Arial"/>
               </a:rPr>
-              <a:t>Break your value down until it becomes something you can actually build:</a:t>
+              <a:t>A persona holds one real user's needs in mind while you build - so you design for someone specific, not "everyone."</a:t>
             </a:r>
           </a:p>
           <a:p>
@@ -5479,54 +7189,13 @@
               </a:lnSpc>
             </a:pPr>
             <a:r>
-              <a:rPr sz="2200" b="0">
-                <a:solidFill>
-                  <a:srgbClr val="F5F7FA"/>
+              <a:rPr sz="1800" b="0">
+                <a:solidFill>
+                  <a:srgbClr val="8A94A6"/>
                 </a:solidFill>
                 <a:latin typeface="Arial"/>
               </a:rPr>
-              <a:t>value  -&gt;  norms  -&gt;  requirements  -&gt;  features  -&gt;  </a:t>
-            </a:r>
-            <a:r>
-              <a:rPr sz="2200" b="1">
-                <a:solidFill>
-                  <a:srgbClr val="00FF41"/>
-                </a:solidFill>
-                <a:latin typeface="Arial"/>
-              </a:rPr>
-              <a:t>the prompts you run tomorrow</a:t>
-            </a:r>
-          </a:p>
-          <a:p>
-            <a:pPr algn="l">
-              <a:lnSpc>
-                <a:spcPct val="112000"/>
-              </a:lnSpc>
-            </a:pPr>
-            <a:r>
-              <a:rPr sz="2000" b="0">
-                <a:solidFill>
-                  <a:srgbClr val="F5F7FA"/>
-                </a:solidFill>
-                <a:latin typeface="Arial"/>
-              </a:rPr>
-              <a:t/>
-            </a:r>
-          </a:p>
-          <a:p>
-            <a:pPr algn="l">
-              <a:lnSpc>
-                <a:spcPct val="112000"/>
-              </a:lnSpc>
-            </a:pPr>
-            <a:r>
-              <a:rPr sz="1700" b="0">
-                <a:solidFill>
-                  <a:srgbClr val="8A94A6"/>
-                </a:solidFill>
-                <a:latin typeface="Arial"/>
-              </a:rPr>
-              <a:t>The bottom of the tree IS your Thursday build plan - the exact prompts, grounded in the value.</a:t>
+              <a:t>The risk: personas flatten people into cliches. Used well they build empathy; used badly they just launder your own assumptions.</a:t>
             </a:r>
           </a:p>
         </p:txBody>
@@ -5630,7 +7299,7 @@
                 </a:solidFill>
                 <a:latin typeface="Courier New"/>
               </a:rPr>
-              <a:t>STORYBOARD IT</a:t>
+              <a:t>GET AS CLOSE TO THE PERSON AS YOU CAN</a:t>
             </a:r>
           </a:p>
         </p:txBody>
@@ -5713,7 +7382,7 @@
                 </a:solidFill>
                 <a:latin typeface="Arial"/>
               </a:rPr>
-              <a:t>4-8 frames: the value in use</a:t>
+              <a:t>Nothing beats real contact</a:t>
             </a:r>
           </a:p>
         </p:txBody>
@@ -5746,14 +7415,21 @@
               </a:lnSpc>
             </a:pPr>
             <a:r>
-              <a:rPr sz="2000" b="1">
-                <a:solidFill>
-                  <a:srgbClr val="00FF41"/>
+              <a:rPr sz="2000" b="0">
+                <a:solidFill>
+                  <a:srgbClr val="F5F7FA"/>
                 </a:solidFill>
                 <a:latin typeface="Arial"/>
               </a:rPr>
-              <a:t>•  </a:t>
-            </a:r>
+              <a:t>Best: talk to a real person - a short interview. Better still: co-design, where the user helps make the thing.</a:t>
+            </a:r>
+          </a:p>
+          <a:p>
+            <a:pPr algn="l">
+              <a:lnSpc>
+                <a:spcPct val="112000"/>
+              </a:lnSpc>
+            </a:pPr>
             <a:r>
               <a:rPr sz="2000" b="0">
                 <a:solidFill>
@@ -5761,7 +7437,7 @@
                 </a:solidFill>
                 <a:latin typeface="Arial"/>
               </a:rPr>
-              <a:t>Frame the user, their problem, where your thing enters, and what changes.</a:t>
+              <a:t/>
             </a:r>
           </a:p>
           <a:p>
@@ -5771,72 +7447,13 @@
               </a:lnSpc>
             </a:pPr>
             <a:r>
-              <a:rPr sz="2000" b="1">
-                <a:solidFill>
-                  <a:srgbClr val="00FF41"/>
+              <a:rPr sz="1800" b="0">
+                <a:solidFill>
+                  <a:srgbClr val="8A94A6"/>
                 </a:solidFill>
                 <a:latin typeface="Arial"/>
               </a:rPr>
-              <a:t>•  </a:t>
-            </a:r>
-            <a:r>
-              <a:rPr sz="2000" b="0">
-                <a:solidFill>
-                  <a:srgbClr val="F5F7FA"/>
-                </a:solidFill>
-                <a:latin typeface="Arial"/>
-              </a:rPr>
-              <a:t>Hand-drawn (photograph it) or AI-assisted - rough is fine.</a:t>
-            </a:r>
-          </a:p>
-          <a:p>
-            <a:pPr algn="l">
-              <a:lnSpc>
-                <a:spcPct val="112000"/>
-              </a:lnSpc>
-            </a:pPr>
-            <a:r>
-              <a:rPr sz="2000" b="1">
-                <a:solidFill>
-                  <a:srgbClr val="00FF41"/>
-                </a:solidFill>
-                <a:latin typeface="Arial"/>
-              </a:rPr>
-              <a:t>•  </a:t>
-            </a:r>
-            <a:r>
-              <a:rPr sz="2000" b="0">
-                <a:solidFill>
-                  <a:srgbClr val="F5F7FA"/>
-                </a:solidFill>
-                <a:latin typeface="Arial"/>
-              </a:rPr>
-              <a:t>It doubles as your Thursday pitch skeleton.</a:t>
-            </a:r>
-          </a:p>
-          <a:p>
-            <a:pPr algn="l">
-              <a:lnSpc>
-                <a:spcPct val="112000"/>
-              </a:lnSpc>
-            </a:pPr>
-            <a:r>
-              <a:rPr sz="2000" b="1">
-                <a:solidFill>
-                  <a:srgbClr val="00FF41"/>
-                </a:solidFill>
-                <a:latin typeface="Arial"/>
-              </a:rPr>
-              <a:t>•  </a:t>
-            </a:r>
-            <a:r>
-              <a:rPr sz="2000" b="0">
-                <a:solidFill>
-                  <a:srgbClr val="F5F7FA"/>
-                </a:solidFill>
-                <a:latin typeface="Arial"/>
-              </a:rPr>
-              <a:t>Show the value living in the design, not just in the copy.</a:t>
+              <a:t>We can't fully do participatory design here - so get as close as you can, and be honest about the gap.</a:t>
             </a:r>
           </a:p>
         </p:txBody>
@@ -5940,7 +7557,7 @@
                 </a:solidFill>
                 <a:latin typeface="Courier New"/>
               </a:rPr>
-              <a:t>TOOLS FOR TODAY</a:t>
+              <a:t>AI PERSONAS - THEATER OR INSIGHT?</a:t>
             </a:r>
           </a:p>
         </p:txBody>
@@ -5997,8 +7614,8 @@
         </p:nvSpPr>
         <p:spPr>
           <a:xfrm>
-            <a:off x="640080" y="1188720"/>
-            <a:ext cx="10972800" cy="1097280"/>
+            <a:off x="640080" y="1325880"/>
+            <a:ext cx="10972800" cy="1828800"/>
           </a:xfrm>
           <a:prstGeom prst="rect">
             <a:avLst/>
@@ -6013,17 +7630,17 @@
           <a:p>
             <a:pPr algn="l">
               <a:lnSpc>
-                <a:spcPct val="100000"/>
-              </a:lnSpc>
-            </a:pPr>
-            <a:r>
-              <a:rPr sz="3400" b="1">
+                <a:spcPct val="105000"/>
+              </a:lnSpc>
+            </a:pPr>
+            <a:r>
+              <a:rPr sz="3800" b="1">
                 <a:solidFill>
                   <a:srgbClr val="F5F7FA"/>
                 </a:solidFill>
                 <a:latin typeface="Arial"/>
               </a:rPr>
-              <a:t>Storyboard + pitch</a:t>
+              <a:t>Make an AI persona, then hold it against a real human.</a:t>
             </a:r>
           </a:p>
         </p:txBody>
@@ -6036,8 +7653,8 @@
         </p:nvSpPr>
         <p:spPr>
           <a:xfrm>
-            <a:off x="658368" y="2286000"/>
-            <a:ext cx="10881360" cy="3657600"/>
+            <a:off x="658368" y="3611880"/>
+            <a:ext cx="10972800" cy="1737360"/>
           </a:xfrm>
           <a:prstGeom prst="rect">
             <a:avLst/>
@@ -6052,133 +7669,177 @@
           <a:p>
             <a:pPr algn="l">
               <a:lnSpc>
-                <a:spcPct val="112000"/>
-              </a:lnSpc>
-            </a:pPr>
-            <a:r>
-              <a:rPr sz="2000" b="1">
+                <a:spcPct val="135000"/>
+              </a:lnSpc>
+            </a:pPr>
+            <a:r>
+              <a:rPr sz="1900" b="1">
                 <a:solidFill>
                   <a:srgbClr val="00FF41"/>
                 </a:solidFill>
                 <a:latin typeface="Arial"/>
               </a:rPr>
-              <a:t>•  </a:t>
-            </a:r>
-            <a:r>
-              <a:rPr sz="2000" b="0">
+              <a:t>→  </a:t>
+            </a:r>
+            <a:r>
+              <a:rPr sz="1900" b="0">
+                <a:solidFill>
+                  <a:srgbClr val="8A94A6"/>
+                </a:solidFill>
+                <a:latin typeface="Arial"/>
+              </a:rPr>
+              <a:t>Generate a persona with AI - even "chat" with the simulated user.</a:t>
+            </a:r>
+          </a:p>
+          <a:p>
+            <a:pPr algn="l">
+              <a:lnSpc>
+                <a:spcPct val="135000"/>
+              </a:lnSpc>
+            </a:pPr>
+            <a:r>
+              <a:rPr sz="1900" b="1">
+                <a:solidFill>
+                  <a:srgbClr val="00FF41"/>
+                </a:solidFill>
+                <a:latin typeface="Arial"/>
+              </a:rPr>
+              <a:t>→  </a:t>
+            </a:r>
+            <a:r>
+              <a:rPr sz="1900" b="0">
+                <a:solidFill>
+                  <a:srgbClr val="8A94A6"/>
+                </a:solidFill>
+                <a:latin typeface="Arial"/>
+              </a:rPr>
+              <a:t>Compare it to the real person you interviewed: what did each get right?</a:t>
+            </a:r>
+          </a:p>
+          <a:p>
+            <a:pPr algn="l">
+              <a:lnSpc>
+                <a:spcPct val="135000"/>
+              </a:lnSpc>
+            </a:pPr>
+            <a:r>
+              <a:rPr sz="1900" b="1">
+                <a:solidFill>
+                  <a:srgbClr val="00FF41"/>
+                </a:solidFill>
+                <a:latin typeface="Arial"/>
+              </a:rPr>
+              <a:t>→  </a:t>
+            </a:r>
+            <a:r>
+              <a:rPr sz="1900" b="0">
+                <a:solidFill>
+                  <a:srgbClr val="8A94A6"/>
+                </a:solidFill>
+                <a:latin typeface="Arial"/>
+              </a:rPr>
+              <a:t>Does the AI theater help you empathize - or hand your own stereotypes back as if they were data?</a:t>
+            </a:r>
+          </a:p>
+        </p:txBody>
+      </p:sp>
+      <p:sp>
+        <p:nvSpPr>
+          <p:cNvPr id="6" name="Rounded Rectangle 5"/>
+          <p:cNvSpPr/>
+          <p:nvPr/>
+        </p:nvSpPr>
+        <p:spPr>
+          <a:xfrm>
+            <a:off x="640080" y="5532120"/>
+            <a:ext cx="10911535" cy="658368"/>
+          </a:xfrm>
+          <a:prstGeom prst="roundRect">
+            <a:avLst/>
+          </a:prstGeom>
+          <a:solidFill>
+            <a:srgbClr val="151B26"/>
+          </a:solidFill>
+          <a:ln w="19050">
+            <a:solidFill>
+              <a:srgbClr val="00FF41"/>
+            </a:solidFill>
+          </a:ln>
+          <a:effectLst/>
+        </p:spPr>
+        <p:style>
+          <a:lnRef idx="1">
+            <a:schemeClr val="accent1"/>
+          </a:lnRef>
+          <a:fillRef idx="3">
+            <a:schemeClr val="accent1"/>
+          </a:fillRef>
+          <a:effectRef idx="2">
+            <a:schemeClr val="accent1"/>
+          </a:effectRef>
+          <a:fontRef idx="minor">
+            <a:schemeClr val="lt1"/>
+          </a:fontRef>
+        </p:style>
+        <p:txBody>
+          <a:bodyPr rtlCol="0" anchor="ctr"/>
+          <a:lstStyle/>
+          <a:p>
+            <a:pPr algn="ctr"/>
+          </a:p>
+        </p:txBody>
+      </p:sp>
+      <p:sp>
+        <p:nvSpPr>
+          <p:cNvPr id="7" name="TextBox 6"/>
+          <p:cNvSpPr txBox="1"/>
+          <p:nvPr/>
+        </p:nvSpPr>
+        <p:spPr>
+          <a:xfrm>
+            <a:off x="914400" y="5532120"/>
+            <a:ext cx="10362895" cy="658368"/>
+          </a:xfrm>
+          <a:prstGeom prst="rect">
+            <a:avLst/>
+          </a:prstGeom>
+          <a:noFill/>
+        </p:spPr>
+        <p:txBody>
+          <a:bodyPr wrap="square" anchor="ctr">
+            <a:spAutoFit/>
+          </a:bodyPr>
+          <a:lstStyle/>
+          <a:p>
+            <a:pPr algn="l">
+              <a:lnSpc>
+                <a:spcPct val="100000"/>
+              </a:lnSpc>
+            </a:pPr>
+            <a:r>
+              <a:rPr sz="1600" b="1">
+                <a:solidFill>
+                  <a:srgbClr val="00FF41"/>
+                </a:solidFill>
+                <a:latin typeface="Arial"/>
+              </a:rPr>
+              <a:t>▶  </a:t>
+            </a:r>
+            <a:r>
+              <a:rPr sz="1600" b="1">
                 <a:solidFill>
                   <a:srgbClr val="F5F7FA"/>
                 </a:solidFill>
                 <a:latin typeface="Arial"/>
               </a:rPr>
-              <a:t>Storyboard: FigJam / Figma, Canva, Google Slides (one frame per slide), or Storyboarder (free &amp; open-source).</a:t>
-            </a:r>
-          </a:p>
-          <a:p>
-            <a:pPr algn="l">
-              <a:lnSpc>
-                <a:spcPct val="112000"/>
-              </a:lnSpc>
-            </a:pPr>
-            <a:r>
-              <a:rPr sz="2000" b="1">
-                <a:solidFill>
-                  <a:srgbClr val="00FF41"/>
-                </a:solidFill>
-                <a:latin typeface="Arial"/>
-              </a:rPr>
-              <a:t>•  </a:t>
-            </a:r>
-            <a:r>
-              <a:rPr sz="2000" b="0">
-                <a:solidFill>
-                  <a:srgbClr val="F5F7FA"/>
-                </a:solidFill>
-                <a:latin typeface="Arial"/>
-              </a:rPr>
-              <a:t>AI pitch video (for Thursday): Google Veo 3.1 (in Flow), Runway, Kling, or Pika.</a:t>
-            </a:r>
-          </a:p>
-          <a:p>
-            <a:pPr algn="l">
-              <a:lnSpc>
-                <a:spcPct val="112000"/>
-              </a:lnSpc>
-            </a:pPr>
-            <a:r>
-              <a:rPr sz="2000" b="1">
-                <a:solidFill>
-                  <a:srgbClr val="00FF41"/>
-                </a:solidFill>
-                <a:latin typeface="Arial"/>
-              </a:rPr>
-              <a:t>•  </a:t>
-            </a:r>
-            <a:r>
-              <a:rPr sz="2000" b="0">
-                <a:solidFill>
-                  <a:srgbClr val="F5F7FA"/>
-                </a:solidFill>
-                <a:latin typeface="Arial"/>
-              </a:rPr>
-              <a:t>Note: OpenAI retired the Sora app in April 2026 - use Veo / Runway / Kling / Pika instead.</a:t>
-            </a:r>
-          </a:p>
-          <a:p>
-            <a:pPr algn="l">
-              <a:lnSpc>
-                <a:spcPct val="112000"/>
-              </a:lnSpc>
-            </a:pPr>
-            <a:r>
-              <a:rPr sz="2000" b="1">
-                <a:solidFill>
-                  <a:srgbClr val="00FF41"/>
-                </a:solidFill>
-                <a:latin typeface="Arial"/>
-              </a:rPr>
-              <a:t>•  </a:t>
-            </a:r>
-            <a:r>
-              <a:rPr sz="2000" b="0">
-                <a:solidFill>
-                  <a:srgbClr val="F5F7FA"/>
-                </a:solidFill>
-                <a:latin typeface="Arial"/>
-              </a:rPr>
-              <a:t>Free tiers add watermarks + limits - fine for a class pitch.</a:t>
-            </a:r>
-          </a:p>
-          <a:p>
-            <a:pPr algn="l">
-              <a:lnSpc>
-                <a:spcPct val="112000"/>
-              </a:lnSpc>
-            </a:pPr>
-            <a:r>
-              <a:rPr sz="2000" b="1">
-                <a:solidFill>
-                  <a:srgbClr val="00FF41"/>
-                </a:solidFill>
-                <a:latin typeface="Arial"/>
-              </a:rPr>
-              <a:t>•  </a:t>
-            </a:r>
-            <a:r>
-              <a:rPr sz="2000" b="0">
-                <a:solidFill>
-                  <a:srgbClr val="F5F7FA"/>
-                </a:solidFill>
-                <a:latin typeface="Arial"/>
-              </a:rPr>
-              <a:t>Interview + persona: just talk to a person; capture notes in FigJam or a doc.</a:t>
-            </a:r>
-          </a:p>
-        </p:txBody>
-      </p:sp>
-      <p:sp>
-        <p:nvSpPr>
-          <p:cNvPr id="6" name="TextBox 5"/>
+              <a:t>Bring BOTH into planning: the AI persona AND one real human's words</a:t>
+            </a:r>
+          </a:p>
+        </p:txBody>
+      </p:sp>
+      <p:sp>
+        <p:nvSpPr>
+          <p:cNvPr id="8" name="TextBox 7"/>
           <p:cNvSpPr txBox="1"/>
           <p:nvPr/>
         </p:nvSpPr>
@@ -6358,7 +8019,7 @@
                 </a:solidFill>
                 <a:latin typeface="Arial"/>
               </a:rPr>
-              <a:t>Show an example</a:t>
+              <a:t>AI persona vs. real interview</a:t>
             </a:r>
           </a:p>
         </p:txBody>
@@ -6444,7 +8105,7 @@
                 </a:solidFill>
                 <a:latin typeface="Courier New"/>
               </a:rPr>
-              <a:t>[ example storyboard or persona goes here ]</a:t>
+              <a:t>[ AI-generated persona + simulator chat, next to your real interview notes ]</a:t>
             </a:r>
           </a:p>
         </p:txBody>
@@ -6483,7 +8144,7 @@
                 </a:solidFill>
                 <a:latin typeface="Arial"/>
               </a:rPr>
-              <a:t>a strong persona, a storyboard, or an AI-pitch still</a:t>
+              <a:t>add the two side by side - where did the AI flatten the person?</a:t>
             </a:r>
           </a:p>
         </p:txBody>
@@ -6587,7 +8248,7 @@
                 </a:solidFill>
                 <a:latin typeface="Courier New"/>
               </a:rPr>
-              <a:t>ACTIVITY - TODAY (TEAM)</a:t>
+              <a:t>KEEP THE VALUE IN THE FOREGROUND</a:t>
             </a:r>
           </a:p>
         </p:txBody>
@@ -6644,8 +8305,8 @@
         </p:nvSpPr>
         <p:spPr>
           <a:xfrm>
-            <a:off x="640080" y="1325880"/>
-            <a:ext cx="10972800" cy="1828800"/>
+            <a:off x="640080" y="1188720"/>
+            <a:ext cx="10972800" cy="1097280"/>
           </a:xfrm>
           <a:prstGeom prst="rect">
             <a:avLst/>
@@ -6660,17 +8321,17 @@
           <a:p>
             <a:pPr algn="l">
               <a:lnSpc>
-                <a:spcPct val="105000"/>
-              </a:lnSpc>
-            </a:pPr>
-            <a:r>
-              <a:rPr sz="3800" b="1">
+                <a:spcPct val="100000"/>
+              </a:lnSpc>
+            </a:pPr>
+            <a:r>
+              <a:rPr sz="3400" b="1">
                 <a:solidFill>
                   <a:srgbClr val="F5F7FA"/>
                 </a:solidFill>
                 <a:latin typeface="Arial"/>
               </a:rPr>
-              <a:t>Plan the next iteration of your value.</a:t>
+              <a:t>Values-conscientious planning</a:t>
             </a:r>
           </a:p>
         </p:txBody>
@@ -6683,8 +8344,8 @@
         </p:nvSpPr>
         <p:spPr>
           <a:xfrm>
-            <a:off x="658368" y="3611880"/>
-            <a:ext cx="10972800" cy="1737360"/>
+            <a:off x="658368" y="2286000"/>
+            <a:ext cx="10881360" cy="3657600"/>
           </a:xfrm>
           <a:prstGeom prst="rect">
             <a:avLst/>
@@ -6699,7 +8360,39 @@
           <a:p>
             <a:pPr algn="l">
               <a:lnSpc>
-                <a:spcPct val="135000"/>
+                <a:spcPct val="112000"/>
+              </a:lnSpc>
+            </a:pPr>
+            <a:r>
+              <a:rPr sz="2000" b="0">
+                <a:solidFill>
+                  <a:srgbClr val="F5F7FA"/>
+                </a:solidFill>
+                <a:latin typeface="Arial"/>
+              </a:rPr>
+              <a:t>Put your value at the front of BOTH artifacts:</a:t>
+            </a:r>
+          </a:p>
+          <a:p>
+            <a:pPr algn="l">
+              <a:lnSpc>
+                <a:spcPct val="112000"/>
+              </a:lnSpc>
+            </a:pPr>
+            <a:r>
+              <a:rPr sz="2000" b="0">
+                <a:solidFill>
+                  <a:srgbClr val="F5F7FA"/>
+                </a:solidFill>
+                <a:latin typeface="Arial"/>
+              </a:rPr>
+              <a:t/>
+            </a:r>
+          </a:p>
+          <a:p>
+            <a:pPr algn="l">
+              <a:lnSpc>
+                <a:spcPct val="112000"/>
               </a:lnSpc>
             </a:pPr>
             <a:r>
@@ -6709,22 +8402,22 @@
                 </a:solidFill>
                 <a:latin typeface="Arial"/>
               </a:rPr>
-              <a:t>→  </a:t>
+              <a:t>Persona</a:t>
             </a:r>
             <a:r>
               <a:rPr sz="1900" b="0">
                 <a:solidFill>
-                  <a:srgbClr val="8A94A6"/>
+                  <a:srgbClr val="F5F7FA"/>
                 </a:solidFill>
                 <a:latin typeface="Arial"/>
               </a:rPr>
-              <a:t>Interview a real person outside the class -&gt; build a persona + the need in their words.</a:t>
-            </a:r>
-          </a:p>
-          <a:p>
-            <a:pPr algn="l">
-              <a:lnSpc>
-                <a:spcPct val="135000"/>
+              <a:t> - where does this user MEET or LOSE the value in their day?</a:t>
+            </a:r>
+          </a:p>
+          <a:p>
+            <a:pPr algn="l">
+              <a:lnSpc>
+                <a:spcPct val="112000"/>
               </a:lnSpc>
             </a:pPr>
             <a:r>
@@ -6734,142 +8427,23 @@
                 </a:solidFill>
                 <a:latin typeface="Arial"/>
               </a:rPr>
-              <a:t>→  </a:t>
+              <a:t>Storyboard</a:t>
             </a:r>
             <a:r>
               <a:rPr sz="1900" b="0">
                 <a:solidFill>
-                  <a:srgbClr val="8A94A6"/>
+                  <a:srgbClr val="F5F7FA"/>
                 </a:solidFill>
                 <a:latin typeface="Arial"/>
               </a:rPr>
-              <a:t>Operationalize: value -&gt; norms -&gt; requirements -&gt; features -&gt; the prompts you'll build.</a:t>
-            </a:r>
-          </a:p>
-          <a:p>
-            <a:pPr algn="l">
-              <a:lnSpc>
-                <a:spcPct val="135000"/>
-              </a:lnSpc>
-            </a:pPr>
-            <a:r>
-              <a:rPr sz="1900" b="1">
-                <a:solidFill>
-                  <a:srgbClr val="00FF41"/>
-                </a:solidFill>
-                <a:latin typeface="Arial"/>
-              </a:rPr>
-              <a:t>→  </a:t>
-            </a:r>
-            <a:r>
-              <a:rPr sz="1900" b="0">
-                <a:solidFill>
-                  <a:srgbClr val="8A94A6"/>
-                </a:solidFill>
-                <a:latin typeface="Arial"/>
-              </a:rPr>
-              <a:t>Storyboard the solution (4-8 frames) and scope the smallest real thing for Thursday.</a:t>
-            </a:r>
-          </a:p>
-        </p:txBody>
-      </p:sp>
-      <p:sp>
-        <p:nvSpPr>
-          <p:cNvPr id="6" name="Rounded Rectangle 5"/>
-          <p:cNvSpPr/>
-          <p:nvPr/>
-        </p:nvSpPr>
-        <p:spPr>
-          <a:xfrm>
-            <a:off x="640080" y="5532120"/>
-            <a:ext cx="10911535" cy="658368"/>
-          </a:xfrm>
-          <a:prstGeom prst="roundRect">
-            <a:avLst/>
-          </a:prstGeom>
-          <a:solidFill>
-            <a:srgbClr val="151B26"/>
-          </a:solidFill>
-          <a:ln w="19050">
-            <a:solidFill>
-              <a:srgbClr val="00FF41"/>
-            </a:solidFill>
-          </a:ln>
-          <a:effectLst/>
-        </p:spPr>
-        <p:style>
-          <a:lnRef idx="1">
-            <a:schemeClr val="accent1"/>
-          </a:lnRef>
-          <a:fillRef idx="3">
-            <a:schemeClr val="accent1"/>
-          </a:fillRef>
-          <a:effectRef idx="2">
-            <a:schemeClr val="accent1"/>
-          </a:effectRef>
-          <a:fontRef idx="minor">
-            <a:schemeClr val="lt1"/>
-          </a:fontRef>
-        </p:style>
-        <p:txBody>
-          <a:bodyPr rtlCol="0" anchor="ctr"/>
-          <a:lstStyle/>
-          <a:p>
-            <a:pPr algn="ctr"/>
-          </a:p>
-        </p:txBody>
-      </p:sp>
-      <p:sp>
-        <p:nvSpPr>
-          <p:cNvPr id="7" name="TextBox 6"/>
-          <p:cNvSpPr txBox="1"/>
-          <p:nvPr/>
-        </p:nvSpPr>
-        <p:spPr>
-          <a:xfrm>
-            <a:off x="914400" y="5532120"/>
-            <a:ext cx="10362895" cy="658368"/>
-          </a:xfrm>
-          <a:prstGeom prst="rect">
-            <a:avLst/>
-          </a:prstGeom>
-          <a:noFill/>
-        </p:spPr>
-        <p:txBody>
-          <a:bodyPr wrap="square" anchor="ctr">
-            <a:spAutoFit/>
-          </a:bodyPr>
-          <a:lstStyle/>
-          <a:p>
-            <a:pPr algn="l">
-              <a:lnSpc>
-                <a:spcPct val="100000"/>
-              </a:lnSpc>
-            </a:pPr>
-            <a:r>
-              <a:rPr sz="1600" b="1">
-                <a:solidFill>
-                  <a:srgbClr val="00FF41"/>
-                </a:solidFill>
-                <a:latin typeface="Arial"/>
-              </a:rPr>
-              <a:t>▶  </a:t>
-            </a:r>
-            <a:r>
-              <a:rPr sz="1600" b="1">
-                <a:solidFill>
-                  <a:srgbClr val="F5F7FA"/>
-                </a:solidFill>
-                <a:latin typeface="Arial"/>
-              </a:rPr>
-              <a:t>Deliverable = planning-report.md + your storyboard - this is Checkpoint 2 of the final</a:t>
-            </a:r>
-          </a:p>
-        </p:txBody>
-      </p:sp>
-      <p:sp>
-        <p:nvSpPr>
-          <p:cNvPr id="8" name="TextBox 7"/>
+              <a:t> - show the value living in each frame: the moment it's supported, defended, or repaired.</a:t>
+            </a:r>
+          </a:p>
+        </p:txBody>
+      </p:sp>
+      <p:sp>
+        <p:nvSpPr>
+          <p:cNvPr id="6" name="TextBox 5"/>
           <p:cNvSpPr txBox="1"/>
           <p:nvPr/>
         </p:nvSpPr>

</xml_diff>

<commit_message>
Monday retitle 'Usability Testing: Can People Use It?' (usability != functionality); Tue opener follows; add NN/g Synthetic Users ref on Wed AI-personas slide
Co-Authored-By: Claude Fable 5 <noreply@anthropic.com>
</commit_message>
<xml_diff>
--- a/slides/Week3-Wed-Working-Day.pptx
+++ b/slides/Week3-Wed-Working-Day.pptx
@@ -516,7 +516,7 @@
           <a:lstStyle/>
           <a:p>
             <a:r>
-              <a:t>AI personas are fast + frictionless but can launder assumptions back as 'data'. Comparing to a real human is the check.</a:t>
+              <a:t>AI personas are fast + frictionless but can launder assumptions back as 'data'. Comparing to a real human is the check. Ref: nngroup.com/articles/synthetic-users/</a:t>
             </a:r>
           </a:p>
         </p:txBody>
@@ -8144,7 +8144,7 @@
                 </a:solidFill>
                 <a:latin typeface="Arial"/>
               </a:rPr>
-              <a:t>add the two side by side - where did the AI flatten the person?</a:t>
+              <a:t>add the two side by side - where did the AI flatten the person?  (skeptical take: NN/g - Synthetic Users)</a:t>
             </a:r>
           </a:p>
         </p:txBody>

</xml_diff>